<commit_message>
Update GUI and Add schsdule window
</commit_message>
<xml_diff>
--- a/img/image.pptx
+++ b/img/image.pptx
@@ -104,6 +104,11 @@
       </a:defRPr>
     </a:lvl9pPr>
   </p:defaultTextStyle>
+  <p:extLst>
+    <p:ext uri="{EFAFB233-063F-42B5-8137-9DF3F51BA10A}">
+      <p15:sldGuideLst xmlns:p15="http://schemas.microsoft.com/office/powerpoint/2012/main"/>
+    </p:ext>
+  </p:extLst>
 </p:presentation>
 </file>
 
@@ -3352,7 +3357,7 @@
         </p:blipFill>
         <p:spPr>
           <a:xfrm>
-            <a:off x="1510558" y="717511"/>
+            <a:off x="1467234" y="435034"/>
             <a:ext cx="914400" cy="914400"/>
           </a:xfrm>
           <a:prstGeom prst="rect">
@@ -3391,7 +3396,7 @@
         </p:blipFill>
         <p:spPr>
           <a:xfrm>
-            <a:off x="2553589" y="717995"/>
+            <a:off x="2541338" y="435034"/>
             <a:ext cx="914400" cy="914400"/>
           </a:xfrm>
           <a:prstGeom prst="rect">
@@ -3430,7 +3435,7 @@
         </p:blipFill>
         <p:spPr>
           <a:xfrm>
-            <a:off x="3565864" y="686961"/>
+            <a:off x="3615442" y="435034"/>
             <a:ext cx="914400" cy="914400"/>
           </a:xfrm>
           <a:prstGeom prst="rect">
@@ -3469,7 +3474,7 @@
         </p:blipFill>
         <p:spPr>
           <a:xfrm>
-            <a:off x="1897443" y="3271800"/>
+            <a:off x="1467234" y="1593000"/>
             <a:ext cx="914400" cy="914400"/>
           </a:xfrm>
           <a:prstGeom prst="rect">
@@ -3508,7 +3513,7 @@
         </p:blipFill>
         <p:spPr>
           <a:xfrm>
-            <a:off x="1822443" y="2507400"/>
+            <a:off x="397644" y="1593000"/>
             <a:ext cx="914400" cy="914400"/>
           </a:xfrm>
           <a:prstGeom prst="rect">
@@ -3547,7 +3552,7 @@
         </p:blipFill>
         <p:spPr>
           <a:xfrm>
-            <a:off x="4643914" y="686961"/>
+            <a:off x="4733542" y="422199"/>
             <a:ext cx="914400" cy="914400"/>
           </a:xfrm>
           <a:prstGeom prst="rect">
@@ -3586,7 +3591,7 @@
         </p:blipFill>
         <p:spPr>
           <a:xfrm>
-            <a:off x="468026" y="689297"/>
+            <a:off x="397644" y="435034"/>
             <a:ext cx="914400" cy="914400"/>
           </a:xfrm>
           <a:prstGeom prst="rect">
@@ -3625,7 +3630,7 @@
         </p:blipFill>
         <p:spPr>
           <a:xfrm>
-            <a:off x="7758843" y="699216"/>
+            <a:off x="1467234" y="2749026"/>
             <a:ext cx="914400" cy="914400"/>
           </a:xfrm>
           <a:prstGeom prst="rect">
@@ -3664,7 +3669,46 @@
         </p:blipFill>
         <p:spPr>
           <a:xfrm>
-            <a:off x="9406902" y="689297"/>
+            <a:off x="2536824" y="2749026"/>
+            <a:ext cx="914400" cy="914400"/>
+          </a:xfrm>
+          <a:prstGeom prst="rect">
+            <a:avLst/>
+          </a:prstGeom>
+        </p:spPr>
+      </p:pic>
+      <p:pic>
+        <p:nvPicPr>
+          <p:cNvPr id="4" name="圖形 3" descr="鉛筆">
+            <a:extLst>
+              <a:ext uri="{FF2B5EF4-FFF2-40B4-BE49-F238E27FC236}">
+                <a16:creationId xmlns:a16="http://schemas.microsoft.com/office/drawing/2014/main" id="{7EEB515B-CF51-4B35-8CE4-922E340C3AE2}"/>
+              </a:ext>
+            </a:extLst>
+          </p:cNvPr>
+          <p:cNvPicPr>
+            <a:picLocks noChangeAspect="1"/>
+          </p:cNvPicPr>
+          <p:nvPr/>
+        </p:nvPicPr>
+        <p:blipFill>
+          <a:blip r:embed="rId20">
+            <a:extLst>
+              <a:ext uri="{28A0092B-C50C-407E-A947-70E740481C1C}">
+                <a14:useLocalDpi xmlns:a14="http://schemas.microsoft.com/office/drawing/2010/main" val="0"/>
+              </a:ext>
+              <a:ext uri="{96DAC541-7B7A-43D3-8B79-37D633B846F1}">
+                <asvg:svgBlip xmlns:asvg="http://schemas.microsoft.com/office/drawing/2016/SVG/main" r:embed="rId21"/>
+              </a:ext>
+            </a:extLst>
+          </a:blip>
+          <a:stretch>
+            <a:fillRect/>
+          </a:stretch>
+        </p:blipFill>
+        <p:spPr>
+          <a:xfrm>
+            <a:off x="397644" y="2749026"/>
             <a:ext cx="914400" cy="914400"/>
           </a:xfrm>
           <a:prstGeom prst="rect">

</xml_diff>

<commit_message>
Fix bug and add icon
</commit_message>
<xml_diff>
--- a/img/image.pptx
+++ b/img/image.pptx
@@ -259,7 +259,7 @@
           <a:p>
             <a:fld id="{91622E0B-5FDE-4522-8756-3F41B41BAF26}" type="datetimeFigureOut">
               <a:rPr lang="zh-TW" altLang="en-US" smtClean="0"/>
-              <a:t>2021/10/24</a:t>
+              <a:t>2021/10/26</a:t>
             </a:fld>
             <a:endParaRPr lang="zh-TW" altLang="en-US"/>
           </a:p>
@@ -457,7 +457,7 @@
           <a:p>
             <a:fld id="{91622E0B-5FDE-4522-8756-3F41B41BAF26}" type="datetimeFigureOut">
               <a:rPr lang="zh-TW" altLang="en-US" smtClean="0"/>
-              <a:t>2021/10/24</a:t>
+              <a:t>2021/10/26</a:t>
             </a:fld>
             <a:endParaRPr lang="zh-TW" altLang="en-US"/>
           </a:p>
@@ -665,7 +665,7 @@
           <a:p>
             <a:fld id="{91622E0B-5FDE-4522-8756-3F41B41BAF26}" type="datetimeFigureOut">
               <a:rPr lang="zh-TW" altLang="en-US" smtClean="0"/>
-              <a:t>2021/10/24</a:t>
+              <a:t>2021/10/26</a:t>
             </a:fld>
             <a:endParaRPr lang="zh-TW" altLang="en-US"/>
           </a:p>
@@ -863,7 +863,7 @@
           <a:p>
             <a:fld id="{91622E0B-5FDE-4522-8756-3F41B41BAF26}" type="datetimeFigureOut">
               <a:rPr lang="zh-TW" altLang="en-US" smtClean="0"/>
-              <a:t>2021/10/24</a:t>
+              <a:t>2021/10/26</a:t>
             </a:fld>
             <a:endParaRPr lang="zh-TW" altLang="en-US"/>
           </a:p>
@@ -1138,7 +1138,7 @@
           <a:p>
             <a:fld id="{91622E0B-5FDE-4522-8756-3F41B41BAF26}" type="datetimeFigureOut">
               <a:rPr lang="zh-TW" altLang="en-US" smtClean="0"/>
-              <a:t>2021/10/24</a:t>
+              <a:t>2021/10/26</a:t>
             </a:fld>
             <a:endParaRPr lang="zh-TW" altLang="en-US"/>
           </a:p>
@@ -1403,7 +1403,7 @@
           <a:p>
             <a:fld id="{91622E0B-5FDE-4522-8756-3F41B41BAF26}" type="datetimeFigureOut">
               <a:rPr lang="zh-TW" altLang="en-US" smtClean="0"/>
-              <a:t>2021/10/24</a:t>
+              <a:t>2021/10/26</a:t>
             </a:fld>
             <a:endParaRPr lang="zh-TW" altLang="en-US"/>
           </a:p>
@@ -1815,7 +1815,7 @@
           <a:p>
             <a:fld id="{91622E0B-5FDE-4522-8756-3F41B41BAF26}" type="datetimeFigureOut">
               <a:rPr lang="zh-TW" altLang="en-US" smtClean="0"/>
-              <a:t>2021/10/24</a:t>
+              <a:t>2021/10/26</a:t>
             </a:fld>
             <a:endParaRPr lang="zh-TW" altLang="en-US"/>
           </a:p>
@@ -1956,7 +1956,7 @@
           <a:p>
             <a:fld id="{91622E0B-5FDE-4522-8756-3F41B41BAF26}" type="datetimeFigureOut">
               <a:rPr lang="zh-TW" altLang="en-US" smtClean="0"/>
-              <a:t>2021/10/24</a:t>
+              <a:t>2021/10/26</a:t>
             </a:fld>
             <a:endParaRPr lang="zh-TW" altLang="en-US"/>
           </a:p>
@@ -2069,7 +2069,7 @@
           <a:p>
             <a:fld id="{91622E0B-5FDE-4522-8756-3F41B41BAF26}" type="datetimeFigureOut">
               <a:rPr lang="zh-TW" altLang="en-US" smtClean="0"/>
-              <a:t>2021/10/24</a:t>
+              <a:t>2021/10/26</a:t>
             </a:fld>
             <a:endParaRPr lang="zh-TW" altLang="en-US"/>
           </a:p>
@@ -2380,7 +2380,7 @@
           <a:p>
             <a:fld id="{91622E0B-5FDE-4522-8756-3F41B41BAF26}" type="datetimeFigureOut">
               <a:rPr lang="zh-TW" altLang="en-US" smtClean="0"/>
-              <a:t>2021/10/24</a:t>
+              <a:t>2021/10/26</a:t>
             </a:fld>
             <a:endParaRPr lang="zh-TW" altLang="en-US"/>
           </a:p>
@@ -2668,7 +2668,7 @@
           <a:p>
             <a:fld id="{91622E0B-5FDE-4522-8756-3F41B41BAF26}" type="datetimeFigureOut">
               <a:rPr lang="zh-TW" altLang="en-US" smtClean="0"/>
-              <a:t>2021/10/24</a:t>
+              <a:t>2021/10/26</a:t>
             </a:fld>
             <a:endParaRPr lang="zh-TW" altLang="en-US"/>
           </a:p>
@@ -2909,7 +2909,7 @@
           <a:p>
             <a:fld id="{91622E0B-5FDE-4522-8756-3F41B41BAF26}" type="datetimeFigureOut">
               <a:rPr lang="zh-TW" altLang="en-US" smtClean="0"/>
-              <a:t>2021/10/24</a:t>
+              <a:t>2021/10/26</a:t>
             </a:fld>
             <a:endParaRPr lang="zh-TW" altLang="en-US"/>
           </a:p>
@@ -3716,6 +3716,45 @@
           </a:prstGeom>
         </p:spPr>
       </p:pic>
+      <p:pic>
+        <p:nvPicPr>
+          <p:cNvPr id="6" name="圖形 5" descr="高音譜記號">
+            <a:extLst>
+              <a:ext uri="{FF2B5EF4-FFF2-40B4-BE49-F238E27FC236}">
+                <a16:creationId xmlns:a16="http://schemas.microsoft.com/office/drawing/2014/main" id="{85FDD46F-5AF0-4B03-A3E6-19238FE18ED3}"/>
+              </a:ext>
+            </a:extLst>
+          </p:cNvPr>
+          <p:cNvPicPr>
+            <a:picLocks noChangeAspect="1"/>
+          </p:cNvPicPr>
+          <p:nvPr/>
+        </p:nvPicPr>
+        <p:blipFill>
+          <a:blip r:embed="rId22">
+            <a:extLst>
+              <a:ext uri="{28A0092B-C50C-407E-A947-70E740481C1C}">
+                <a14:useLocalDpi xmlns:a14="http://schemas.microsoft.com/office/drawing/2010/main" val="0"/>
+              </a:ext>
+              <a:ext uri="{96DAC541-7B7A-43D3-8B79-37D633B846F1}">
+                <asvg:svgBlip xmlns:asvg="http://schemas.microsoft.com/office/drawing/2016/SVG/main" r:embed="rId23"/>
+              </a:ext>
+            </a:extLst>
+          </a:blip>
+          <a:stretch>
+            <a:fillRect/>
+          </a:stretch>
+        </p:blipFill>
+        <p:spPr>
+          <a:xfrm>
+            <a:off x="397644" y="3905052"/>
+            <a:ext cx="914400" cy="914400"/>
+          </a:xfrm>
+          <a:prstGeom prst="rect">
+            <a:avLst/>
+          </a:prstGeom>
+        </p:spPr>
+      </p:pic>
     </p:spTree>
     <p:extLst>
       <p:ext uri="{BB962C8B-B14F-4D97-AF65-F5344CB8AC3E}">

</xml_diff>